<commit_message>
Treduccion de los elementos para grupo pequeños
</commit_message>
<xml_diff>
--- a/El_Aterrizaje_Conferencia_Luz_y_Esperanza.pptx
+++ b/El_Aterrizaje_Conferencia_Luz_y_Esperanza.pptx
@@ -4,25 +4,25 @@
   <p:sldMasterIdLst>
     <p:sldMasterId id="2147483648" r:id="rId1"/>
   </p:sldMasterIdLst>
+  <p:notesMasterIdLst>
+    <p:notesMasterId r:id="rId17"/>
+  </p:notesMasterIdLst>
   <p:sldIdLst>
-    <p:sldId id="256" r:id="rId7"/>
-    <p:sldId id="257" r:id="rId8"/>
-    <p:sldId id="258" r:id="rId9"/>
-    <p:sldId id="259" r:id="rId10"/>
-    <p:sldId id="260" r:id="rId11"/>
-    <p:sldId id="261" r:id="rId12"/>
-    <p:sldId id="262" r:id="rId13"/>
-    <p:sldId id="263" r:id="rId14"/>
-    <p:sldId id="264" r:id="rId15"/>
-    <p:sldId id="265" r:id="rId16"/>
-    <p:sldId id="266" r:id="rId17"/>
-    <p:sldId id="267" r:id="rId18"/>
-    <p:sldId id="268" r:id="rId19"/>
-    <p:sldId id="269" r:id="rId20"/>
-    <p:sldId id="270" r:id="rId21"/>
-    <p:sldId id="271" r:id="rId22"/>
-    <p:sldId id="272" r:id="rId23"/>
-    <p:sldId id="273" r:id="rId24"/>
+    <p:sldId id="259" r:id="rId2"/>
+    <p:sldId id="260" r:id="rId3"/>
+    <p:sldId id="261" r:id="rId4"/>
+    <p:sldId id="262" r:id="rId5"/>
+    <p:sldId id="263" r:id="rId6"/>
+    <p:sldId id="264" r:id="rId7"/>
+    <p:sldId id="265" r:id="rId8"/>
+    <p:sldId id="266" r:id="rId9"/>
+    <p:sldId id="267" r:id="rId10"/>
+    <p:sldId id="268" r:id="rId11"/>
+    <p:sldId id="269" r:id="rId12"/>
+    <p:sldId id="270" r:id="rId13"/>
+    <p:sldId id="271" r:id="rId14"/>
+    <p:sldId id="272" r:id="rId15"/>
+    <p:sldId id="273" r:id="rId16"/>
   </p:sldIdLst>
   <p:sldSz cx="9144000" cy="6858000" type="screen4x3"/>
   <p:notesSz cx="6858000" cy="9144000"/>
@@ -121,7 +121,373 @@
       </a:defRPr>
     </a:lvl9pPr>
   </p:defaultTextStyle>
+  <p:extLst>
+    <p:ext uri="{EFAFB233-063F-42B5-8137-9DF3F51BA10A}">
+      <p15:sldGuideLst xmlns:p15="http://schemas.microsoft.com/office/powerpoint/2012/main">
+        <p15:guide id="1" orient="horz" pos="2160">
+          <p15:clr>
+            <a:srgbClr val="A4A3A4"/>
+          </p15:clr>
+        </p15:guide>
+        <p15:guide id="2" pos="2880">
+          <p15:clr>
+            <a:srgbClr val="A4A3A4"/>
+          </p15:clr>
+        </p15:guide>
+      </p15:sldGuideLst>
+    </p:ext>
+  </p:extLst>
 </p:presentation>
+</file>
+
+<file path=ppt/notesMasters/notesMaster1.xml><?xml version="1.0" encoding="utf-8"?>
+<p:notesMaster xmlns:a="http://schemas.openxmlformats.org/drawingml/2006/main" xmlns:r="http://schemas.openxmlformats.org/officeDocument/2006/relationships" xmlns:p="http://schemas.openxmlformats.org/presentationml/2006/main">
+  <p:cSld>
+    <p:bg>
+      <p:bgRef idx="1001">
+        <a:schemeClr val="bg1"/>
+      </p:bgRef>
+    </p:bg>
+    <p:spTree>
+      <p:nvGrpSpPr>
+        <p:cNvPr id="1" name=""/>
+        <p:cNvGrpSpPr/>
+        <p:nvPr/>
+      </p:nvGrpSpPr>
+      <p:grpSpPr>
+        <a:xfrm>
+          <a:off x="0" y="0"/>
+          <a:ext cx="0" cy="0"/>
+          <a:chOff x="0" y="0"/>
+          <a:chExt cx="0" cy="0"/>
+        </a:xfrm>
+      </p:grpSpPr>
+      <p:sp>
+        <p:nvSpPr>
+          <p:cNvPr id="2" name="Marcador de encabezado 1"/>
+          <p:cNvSpPr>
+            <a:spLocks noGrp="1"/>
+          </p:cNvSpPr>
+          <p:nvPr>
+            <p:ph type="hdr" sz="quarter"/>
+          </p:nvPr>
+        </p:nvSpPr>
+        <p:spPr>
+          <a:xfrm>
+            <a:off x="0" y="0"/>
+            <a:ext cx="2971800" cy="458788"/>
+          </a:xfrm>
+          <a:prstGeom prst="rect">
+            <a:avLst/>
+          </a:prstGeom>
+        </p:spPr>
+        <p:txBody>
+          <a:bodyPr vert="horz" lIns="91440" tIns="45720" rIns="91440" bIns="45720" rtlCol="0"/>
+          <a:lstStyle>
+            <a:lvl1pPr algn="l">
+              <a:defRPr sz="1200"/>
+            </a:lvl1pPr>
+          </a:lstStyle>
+          <a:p>
+            <a:endParaRPr lang="es-AR"/>
+          </a:p>
+        </p:txBody>
+      </p:sp>
+      <p:sp>
+        <p:nvSpPr>
+          <p:cNvPr id="3" name="Marcador de fecha 2"/>
+          <p:cNvSpPr>
+            <a:spLocks noGrp="1"/>
+          </p:cNvSpPr>
+          <p:nvPr>
+            <p:ph type="dt" idx="1"/>
+          </p:nvPr>
+        </p:nvSpPr>
+        <p:spPr>
+          <a:xfrm>
+            <a:off x="3884613" y="0"/>
+            <a:ext cx="2971800" cy="458788"/>
+          </a:xfrm>
+          <a:prstGeom prst="rect">
+            <a:avLst/>
+          </a:prstGeom>
+        </p:spPr>
+        <p:txBody>
+          <a:bodyPr vert="horz" lIns="91440" tIns="45720" rIns="91440" bIns="45720" rtlCol="0"/>
+          <a:lstStyle>
+            <a:lvl1pPr algn="r">
+              <a:defRPr sz="1200"/>
+            </a:lvl1pPr>
+          </a:lstStyle>
+          <a:p>
+            <a:fld id="{3BD58195-1012-4F64-9803-D918A09DF5FC}" type="datetimeFigureOut">
+              <a:rPr lang="es-AR" smtClean="0"/>
+              <a:t>22/10/2025</a:t>
+            </a:fld>
+            <a:endParaRPr lang="es-AR"/>
+          </a:p>
+        </p:txBody>
+      </p:sp>
+      <p:sp>
+        <p:nvSpPr>
+          <p:cNvPr id="4" name="Marcador de imagen de diapositiva 3"/>
+          <p:cNvSpPr>
+            <a:spLocks noGrp="1" noRot="1" noChangeAspect="1"/>
+          </p:cNvSpPr>
+          <p:nvPr>
+            <p:ph type="sldImg" idx="2"/>
+          </p:nvPr>
+        </p:nvSpPr>
+        <p:spPr>
+          <a:xfrm>
+            <a:off x="1371600" y="1143000"/>
+            <a:ext cx="4114800" cy="3086100"/>
+          </a:xfrm>
+          <a:prstGeom prst="rect">
+            <a:avLst/>
+          </a:prstGeom>
+          <a:noFill/>
+          <a:ln w="12700">
+            <a:solidFill>
+              <a:prstClr val="black"/>
+            </a:solidFill>
+          </a:ln>
+        </p:spPr>
+        <p:txBody>
+          <a:bodyPr vert="horz" lIns="91440" tIns="45720" rIns="91440" bIns="45720" rtlCol="0" anchor="ctr"/>
+          <a:lstStyle/>
+          <a:p>
+            <a:endParaRPr lang="es-AR"/>
+          </a:p>
+        </p:txBody>
+      </p:sp>
+      <p:sp>
+        <p:nvSpPr>
+          <p:cNvPr id="5" name="Marcador de notas 4"/>
+          <p:cNvSpPr>
+            <a:spLocks noGrp="1"/>
+          </p:cNvSpPr>
+          <p:nvPr>
+            <p:ph type="body" sz="quarter" idx="3"/>
+          </p:nvPr>
+        </p:nvSpPr>
+        <p:spPr>
+          <a:xfrm>
+            <a:off x="685800" y="4400550"/>
+            <a:ext cx="5486400" cy="3600450"/>
+          </a:xfrm>
+          <a:prstGeom prst="rect">
+            <a:avLst/>
+          </a:prstGeom>
+        </p:spPr>
+        <p:txBody>
+          <a:bodyPr vert="horz" lIns="91440" tIns="45720" rIns="91440" bIns="45720" rtlCol="0"/>
+          <a:lstStyle/>
+          <a:p>
+            <a:pPr lvl="0"/>
+            <a:r>
+              <a:rPr lang="es-ES"/>
+              <a:t>Haga clic para modificar los estilos de texto del patrón</a:t>
+            </a:r>
+          </a:p>
+          <a:p>
+            <a:pPr lvl="1"/>
+            <a:r>
+              <a:rPr lang="es-ES"/>
+              <a:t>Segundo nivel</a:t>
+            </a:r>
+          </a:p>
+          <a:p>
+            <a:pPr lvl="2"/>
+            <a:r>
+              <a:rPr lang="es-ES"/>
+              <a:t>Tercer nivel</a:t>
+            </a:r>
+          </a:p>
+          <a:p>
+            <a:pPr lvl="3"/>
+            <a:r>
+              <a:rPr lang="es-ES"/>
+              <a:t>Cuarto nivel</a:t>
+            </a:r>
+          </a:p>
+          <a:p>
+            <a:pPr lvl="4"/>
+            <a:r>
+              <a:rPr lang="es-ES"/>
+              <a:t>Quinto nivel</a:t>
+            </a:r>
+            <a:endParaRPr lang="es-AR"/>
+          </a:p>
+        </p:txBody>
+      </p:sp>
+      <p:sp>
+        <p:nvSpPr>
+          <p:cNvPr id="6" name="Marcador de pie de página 5"/>
+          <p:cNvSpPr>
+            <a:spLocks noGrp="1"/>
+          </p:cNvSpPr>
+          <p:nvPr>
+            <p:ph type="ftr" sz="quarter" idx="4"/>
+          </p:nvPr>
+        </p:nvSpPr>
+        <p:spPr>
+          <a:xfrm>
+            <a:off x="0" y="8685213"/>
+            <a:ext cx="2971800" cy="458787"/>
+          </a:xfrm>
+          <a:prstGeom prst="rect">
+            <a:avLst/>
+          </a:prstGeom>
+        </p:spPr>
+        <p:txBody>
+          <a:bodyPr vert="horz" lIns="91440" tIns="45720" rIns="91440" bIns="45720" rtlCol="0" anchor="b"/>
+          <a:lstStyle>
+            <a:lvl1pPr algn="l">
+              <a:defRPr sz="1200"/>
+            </a:lvl1pPr>
+          </a:lstStyle>
+          <a:p>
+            <a:endParaRPr lang="es-AR"/>
+          </a:p>
+        </p:txBody>
+      </p:sp>
+      <p:sp>
+        <p:nvSpPr>
+          <p:cNvPr id="7" name="Marcador de número de diapositiva 6"/>
+          <p:cNvSpPr>
+            <a:spLocks noGrp="1"/>
+          </p:cNvSpPr>
+          <p:nvPr>
+            <p:ph type="sldNum" sz="quarter" idx="5"/>
+          </p:nvPr>
+        </p:nvSpPr>
+        <p:spPr>
+          <a:xfrm>
+            <a:off x="3884613" y="8685213"/>
+            <a:ext cx="2971800" cy="458787"/>
+          </a:xfrm>
+          <a:prstGeom prst="rect">
+            <a:avLst/>
+          </a:prstGeom>
+        </p:spPr>
+        <p:txBody>
+          <a:bodyPr vert="horz" lIns="91440" tIns="45720" rIns="91440" bIns="45720" rtlCol="0" anchor="b"/>
+          <a:lstStyle>
+            <a:lvl1pPr algn="r">
+              <a:defRPr sz="1200"/>
+            </a:lvl1pPr>
+          </a:lstStyle>
+          <a:p>
+            <a:fld id="{8A94C1BC-06D5-4761-BC7C-BC478E230A94}" type="slidenum">
+              <a:rPr lang="es-AR" smtClean="0"/>
+              <a:t>‹Nº›</a:t>
+            </a:fld>
+            <a:endParaRPr lang="es-AR"/>
+          </a:p>
+        </p:txBody>
+      </p:sp>
+    </p:spTree>
+    <p:extLst>
+      <p:ext uri="{BB962C8B-B14F-4D97-AF65-F5344CB8AC3E}">
+        <p14:creationId xmlns:p14="http://schemas.microsoft.com/office/powerpoint/2010/main" val="2466471960"/>
+      </p:ext>
+    </p:extLst>
+  </p:cSld>
+  <p:clrMap bg1="lt1" tx1="dk1" bg2="lt2" tx2="dk2" accent1="accent1" accent2="accent2" accent3="accent3" accent4="accent4" accent5="accent5" accent6="accent6" hlink="hlink" folHlink="folHlink"/>
+  <p:notesStyle>
+    <a:lvl1pPr marL="0" algn="l" defTabSz="914400" rtl="0" eaLnBrk="1" latinLnBrk="0" hangingPunct="1">
+      <a:defRPr sz="1200" kern="1200">
+        <a:solidFill>
+          <a:schemeClr val="tx1"/>
+        </a:solidFill>
+        <a:latin typeface="+mn-lt"/>
+        <a:ea typeface="+mn-ea"/>
+        <a:cs typeface="+mn-cs"/>
+      </a:defRPr>
+    </a:lvl1pPr>
+    <a:lvl2pPr marL="457200" algn="l" defTabSz="914400" rtl="0" eaLnBrk="1" latinLnBrk="0" hangingPunct="1">
+      <a:defRPr sz="1200" kern="1200">
+        <a:solidFill>
+          <a:schemeClr val="tx1"/>
+        </a:solidFill>
+        <a:latin typeface="+mn-lt"/>
+        <a:ea typeface="+mn-ea"/>
+        <a:cs typeface="+mn-cs"/>
+      </a:defRPr>
+    </a:lvl2pPr>
+    <a:lvl3pPr marL="914400" algn="l" defTabSz="914400" rtl="0" eaLnBrk="1" latinLnBrk="0" hangingPunct="1">
+      <a:defRPr sz="1200" kern="1200">
+        <a:solidFill>
+          <a:schemeClr val="tx1"/>
+        </a:solidFill>
+        <a:latin typeface="+mn-lt"/>
+        <a:ea typeface="+mn-ea"/>
+        <a:cs typeface="+mn-cs"/>
+      </a:defRPr>
+    </a:lvl3pPr>
+    <a:lvl4pPr marL="1371600" algn="l" defTabSz="914400" rtl="0" eaLnBrk="1" latinLnBrk="0" hangingPunct="1">
+      <a:defRPr sz="1200" kern="1200">
+        <a:solidFill>
+          <a:schemeClr val="tx1"/>
+        </a:solidFill>
+        <a:latin typeface="+mn-lt"/>
+        <a:ea typeface="+mn-ea"/>
+        <a:cs typeface="+mn-cs"/>
+      </a:defRPr>
+    </a:lvl4pPr>
+    <a:lvl5pPr marL="1828800" algn="l" defTabSz="914400" rtl="0" eaLnBrk="1" latinLnBrk="0" hangingPunct="1">
+      <a:defRPr sz="1200" kern="1200">
+        <a:solidFill>
+          <a:schemeClr val="tx1"/>
+        </a:solidFill>
+        <a:latin typeface="+mn-lt"/>
+        <a:ea typeface="+mn-ea"/>
+        <a:cs typeface="+mn-cs"/>
+      </a:defRPr>
+    </a:lvl5pPr>
+    <a:lvl6pPr marL="2286000" algn="l" defTabSz="914400" rtl="0" eaLnBrk="1" latinLnBrk="0" hangingPunct="1">
+      <a:defRPr sz="1200" kern="1200">
+        <a:solidFill>
+          <a:schemeClr val="tx1"/>
+        </a:solidFill>
+        <a:latin typeface="+mn-lt"/>
+        <a:ea typeface="+mn-ea"/>
+        <a:cs typeface="+mn-cs"/>
+      </a:defRPr>
+    </a:lvl6pPr>
+    <a:lvl7pPr marL="2743200" algn="l" defTabSz="914400" rtl="0" eaLnBrk="1" latinLnBrk="0" hangingPunct="1">
+      <a:defRPr sz="1200" kern="1200">
+        <a:solidFill>
+          <a:schemeClr val="tx1"/>
+        </a:solidFill>
+        <a:latin typeface="+mn-lt"/>
+        <a:ea typeface="+mn-ea"/>
+        <a:cs typeface="+mn-cs"/>
+      </a:defRPr>
+    </a:lvl7pPr>
+    <a:lvl8pPr marL="3200400" algn="l" defTabSz="914400" rtl="0" eaLnBrk="1" latinLnBrk="0" hangingPunct="1">
+      <a:defRPr sz="1200" kern="1200">
+        <a:solidFill>
+          <a:schemeClr val="tx1"/>
+        </a:solidFill>
+        <a:latin typeface="+mn-lt"/>
+        <a:ea typeface="+mn-ea"/>
+        <a:cs typeface="+mn-cs"/>
+      </a:defRPr>
+    </a:lvl8pPr>
+    <a:lvl9pPr marL="3657600" algn="l" defTabSz="914400" rtl="0" eaLnBrk="1" latinLnBrk="0" hangingPunct="1">
+      <a:defRPr sz="1200" kern="1200">
+        <a:solidFill>
+          <a:schemeClr val="tx1"/>
+        </a:solidFill>
+        <a:latin typeface="+mn-lt"/>
+        <a:ea typeface="+mn-ea"/>
+        <a:cs typeface="+mn-cs"/>
+      </a:defRPr>
+    </a:lvl9pPr>
+  </p:notesStyle>
+</p:notesMaster>
 </file>
 
 <file path=ppt/slideLayouts/slideLayout1.xml><?xml version="1.0" encoding="utf-8"?>
@@ -162,10 +528,9 @@
           <a:lstStyle/>
           <a:p>
             <a:r>
-              <a:rPr lang="en-US" smtClean="0"/>
+              <a:rPr lang="en-US"/>
               <a:t>Click to edit Master title style</a:t>
             </a:r>
-            <a:endParaRPr lang="en-US"/>
           </a:p>
         </p:txBody>
       </p:sp>
@@ -281,10 +646,9 @@
           </a:lstStyle>
           <a:p>
             <a:r>
-              <a:rPr lang="en-US" smtClean="0"/>
+              <a:rPr lang="en-US"/>
               <a:t>Click to edit Master subtitle style</a:t>
             </a:r>
-            <a:endParaRPr lang="en-US"/>
           </a:p>
         </p:txBody>
       </p:sp>
@@ -305,7 +669,7 @@
           <a:p>
             <a:fld id="{5BCAD085-E8A6-8845-BD4E-CB4CCA059FC4}" type="datetimeFigureOut">
               <a:rPr lang="en-US" smtClean="0"/>
-              <a:t>1/27/13</a:t>
+              <a:t>10/22/2025</a:t>
             </a:fld>
             <a:endParaRPr lang="en-US"/>
           </a:p>
@@ -347,7 +711,7 @@
           <a:p>
             <a:fld id="{C1FF6DA9-008F-8B48-92A6-B652298478BF}" type="slidenum">
               <a:rPr lang="en-US" smtClean="0"/>
-              <a:t>‹#›</a:t>
+              <a:t>‹Nº›</a:t>
             </a:fld>
             <a:endParaRPr lang="en-US"/>
           </a:p>
@@ -399,10 +763,9 @@
           <a:lstStyle/>
           <a:p>
             <a:r>
-              <a:rPr lang="en-US" smtClean="0"/>
+              <a:rPr lang="en-US"/>
               <a:t>Click to edit Master title style</a:t>
             </a:r>
-            <a:endParaRPr lang="en-US"/>
           </a:p>
         </p:txBody>
       </p:sp>
@@ -423,38 +786,37 @@
           <a:p>
             <a:pPr lvl="0"/>
             <a:r>
-              <a:rPr lang="en-US" smtClean="0"/>
+              <a:rPr lang="en-US"/>
               <a:t>Click to edit Master text styles</a:t>
             </a:r>
           </a:p>
           <a:p>
             <a:pPr lvl="1"/>
             <a:r>
-              <a:rPr lang="en-US" smtClean="0"/>
+              <a:rPr lang="en-US"/>
               <a:t>Second level</a:t>
             </a:r>
           </a:p>
           <a:p>
             <a:pPr lvl="2"/>
             <a:r>
-              <a:rPr lang="en-US" smtClean="0"/>
+              <a:rPr lang="en-US"/>
               <a:t>Third level</a:t>
             </a:r>
           </a:p>
           <a:p>
             <a:pPr lvl="3"/>
             <a:r>
-              <a:rPr lang="en-US" smtClean="0"/>
+              <a:rPr lang="en-US"/>
               <a:t>Fourth level</a:t>
             </a:r>
           </a:p>
           <a:p>
             <a:pPr lvl="4"/>
             <a:r>
-              <a:rPr lang="en-US" smtClean="0"/>
+              <a:rPr lang="en-US"/>
               <a:t>Fifth level</a:t>
             </a:r>
-            <a:endParaRPr lang="en-US"/>
           </a:p>
         </p:txBody>
       </p:sp>
@@ -475,7 +837,7 @@
           <a:p>
             <a:fld id="{5BCAD085-E8A6-8845-BD4E-CB4CCA059FC4}" type="datetimeFigureOut">
               <a:rPr lang="en-US" smtClean="0"/>
-              <a:t>1/27/13</a:t>
+              <a:t>10/22/2025</a:t>
             </a:fld>
             <a:endParaRPr lang="en-US"/>
           </a:p>
@@ -517,7 +879,7 @@
           <a:p>
             <a:fld id="{C1FF6DA9-008F-8B48-92A6-B652298478BF}" type="slidenum">
               <a:rPr lang="en-US" smtClean="0"/>
-              <a:t>‹#›</a:t>
+              <a:t>‹Nº›</a:t>
             </a:fld>
             <a:endParaRPr lang="en-US"/>
           </a:p>
@@ -574,10 +936,9 @@
           <a:lstStyle/>
           <a:p>
             <a:r>
-              <a:rPr lang="en-US" smtClean="0"/>
+              <a:rPr lang="en-US"/>
               <a:t>Click to edit Master title style</a:t>
             </a:r>
-            <a:endParaRPr lang="en-US"/>
           </a:p>
         </p:txBody>
       </p:sp>
@@ -603,38 +964,37 @@
           <a:p>
             <a:pPr lvl="0"/>
             <a:r>
-              <a:rPr lang="en-US" smtClean="0"/>
+              <a:rPr lang="en-US"/>
               <a:t>Click to edit Master text styles</a:t>
             </a:r>
           </a:p>
           <a:p>
             <a:pPr lvl="1"/>
             <a:r>
-              <a:rPr lang="en-US" smtClean="0"/>
+              <a:rPr lang="en-US"/>
               <a:t>Second level</a:t>
             </a:r>
           </a:p>
           <a:p>
             <a:pPr lvl="2"/>
             <a:r>
-              <a:rPr lang="en-US" smtClean="0"/>
+              <a:rPr lang="en-US"/>
               <a:t>Third level</a:t>
             </a:r>
           </a:p>
           <a:p>
             <a:pPr lvl="3"/>
             <a:r>
-              <a:rPr lang="en-US" smtClean="0"/>
+              <a:rPr lang="en-US"/>
               <a:t>Fourth level</a:t>
             </a:r>
           </a:p>
           <a:p>
             <a:pPr lvl="4"/>
             <a:r>
-              <a:rPr lang="en-US" smtClean="0"/>
+              <a:rPr lang="en-US"/>
               <a:t>Fifth level</a:t>
             </a:r>
-            <a:endParaRPr lang="en-US"/>
           </a:p>
         </p:txBody>
       </p:sp>
@@ -655,7 +1015,7 @@
           <a:p>
             <a:fld id="{5BCAD085-E8A6-8845-BD4E-CB4CCA059FC4}" type="datetimeFigureOut">
               <a:rPr lang="en-US" smtClean="0"/>
-              <a:t>1/27/13</a:t>
+              <a:t>10/22/2025</a:t>
             </a:fld>
             <a:endParaRPr lang="en-US"/>
           </a:p>
@@ -697,7 +1057,7 @@
           <a:p>
             <a:fld id="{C1FF6DA9-008F-8B48-92A6-B652298478BF}" type="slidenum">
               <a:rPr lang="en-US" smtClean="0"/>
-              <a:t>‹#›</a:t>
+              <a:t>‹Nº›</a:t>
             </a:fld>
             <a:endParaRPr lang="en-US"/>
           </a:p>
@@ -749,10 +1109,9 @@
           <a:lstStyle/>
           <a:p>
             <a:r>
-              <a:rPr lang="en-US" smtClean="0"/>
+              <a:rPr lang="en-US"/>
               <a:t>Click to edit Master title style</a:t>
             </a:r>
-            <a:endParaRPr lang="en-US"/>
           </a:p>
         </p:txBody>
       </p:sp>
@@ -773,38 +1132,37 @@
           <a:p>
             <a:pPr lvl="0"/>
             <a:r>
-              <a:rPr lang="en-US" smtClean="0"/>
+              <a:rPr lang="en-US"/>
               <a:t>Click to edit Master text styles</a:t>
             </a:r>
           </a:p>
           <a:p>
             <a:pPr lvl="1"/>
             <a:r>
-              <a:rPr lang="en-US" smtClean="0"/>
+              <a:rPr lang="en-US"/>
               <a:t>Second level</a:t>
             </a:r>
           </a:p>
           <a:p>
             <a:pPr lvl="2"/>
             <a:r>
-              <a:rPr lang="en-US" smtClean="0"/>
+              <a:rPr lang="en-US"/>
               <a:t>Third level</a:t>
             </a:r>
           </a:p>
           <a:p>
             <a:pPr lvl="3"/>
             <a:r>
-              <a:rPr lang="en-US" smtClean="0"/>
+              <a:rPr lang="en-US"/>
               <a:t>Fourth level</a:t>
             </a:r>
           </a:p>
           <a:p>
             <a:pPr lvl="4"/>
             <a:r>
-              <a:rPr lang="en-US" smtClean="0"/>
+              <a:rPr lang="en-US"/>
               <a:t>Fifth level</a:t>
             </a:r>
-            <a:endParaRPr lang="en-US"/>
           </a:p>
         </p:txBody>
       </p:sp>
@@ -825,7 +1183,7 @@
           <a:p>
             <a:fld id="{5BCAD085-E8A6-8845-BD4E-CB4CCA059FC4}" type="datetimeFigureOut">
               <a:rPr lang="en-US" smtClean="0"/>
-              <a:t>1/27/13</a:t>
+              <a:t>10/22/2025</a:t>
             </a:fld>
             <a:endParaRPr lang="en-US"/>
           </a:p>
@@ -867,7 +1225,7 @@
           <a:p>
             <a:fld id="{C1FF6DA9-008F-8B48-92A6-B652298478BF}" type="slidenum">
               <a:rPr lang="en-US" smtClean="0"/>
-              <a:t>‹#›</a:t>
+              <a:t>‹Nº›</a:t>
             </a:fld>
             <a:endParaRPr lang="en-US"/>
           </a:p>
@@ -928,10 +1286,9 @@
           </a:lstStyle>
           <a:p>
             <a:r>
-              <a:rPr lang="en-US" smtClean="0"/>
+              <a:rPr lang="en-US"/>
               <a:t>Click to edit Master title style</a:t>
             </a:r>
-            <a:endParaRPr lang="en-US"/>
           </a:p>
         </p:txBody>
       </p:sp>
@@ -1048,7 +1405,7 @@
           <a:p>
             <a:pPr lvl="0"/>
             <a:r>
-              <a:rPr lang="en-US" smtClean="0"/>
+              <a:rPr lang="en-US"/>
               <a:t>Click to edit Master text styles</a:t>
             </a:r>
           </a:p>
@@ -1071,7 +1428,7 @@
           <a:p>
             <a:fld id="{5BCAD085-E8A6-8845-BD4E-CB4CCA059FC4}" type="datetimeFigureOut">
               <a:rPr lang="en-US" smtClean="0"/>
-              <a:t>1/27/13</a:t>
+              <a:t>10/22/2025</a:t>
             </a:fld>
             <a:endParaRPr lang="en-US"/>
           </a:p>
@@ -1113,7 +1470,7 @@
           <a:p>
             <a:fld id="{C1FF6DA9-008F-8B48-92A6-B652298478BF}" type="slidenum">
               <a:rPr lang="en-US" smtClean="0"/>
-              <a:t>‹#›</a:t>
+              <a:t>‹Nº›</a:t>
             </a:fld>
             <a:endParaRPr lang="en-US"/>
           </a:p>
@@ -1165,10 +1522,9 @@
           <a:lstStyle/>
           <a:p>
             <a:r>
-              <a:rPr lang="en-US" smtClean="0"/>
+              <a:rPr lang="en-US"/>
               <a:t>Click to edit Master title style</a:t>
             </a:r>
-            <a:endParaRPr lang="en-US"/>
           </a:p>
         </p:txBody>
       </p:sp>
@@ -1222,38 +1578,37 @@
           <a:p>
             <a:pPr lvl="0"/>
             <a:r>
-              <a:rPr lang="en-US" smtClean="0"/>
+              <a:rPr lang="en-US"/>
               <a:t>Click to edit Master text styles</a:t>
             </a:r>
           </a:p>
           <a:p>
             <a:pPr lvl="1"/>
             <a:r>
-              <a:rPr lang="en-US" smtClean="0"/>
+              <a:rPr lang="en-US"/>
               <a:t>Second level</a:t>
             </a:r>
           </a:p>
           <a:p>
             <a:pPr lvl="2"/>
             <a:r>
-              <a:rPr lang="en-US" smtClean="0"/>
+              <a:rPr lang="en-US"/>
               <a:t>Third level</a:t>
             </a:r>
           </a:p>
           <a:p>
             <a:pPr lvl="3"/>
             <a:r>
-              <a:rPr lang="en-US" smtClean="0"/>
+              <a:rPr lang="en-US"/>
               <a:t>Fourth level</a:t>
             </a:r>
           </a:p>
           <a:p>
             <a:pPr lvl="4"/>
             <a:r>
-              <a:rPr lang="en-US" smtClean="0"/>
+              <a:rPr lang="en-US"/>
               <a:t>Fifth level</a:t>
             </a:r>
-            <a:endParaRPr lang="en-US"/>
           </a:p>
         </p:txBody>
       </p:sp>
@@ -1307,38 +1662,37 @@
           <a:p>
             <a:pPr lvl="0"/>
             <a:r>
-              <a:rPr lang="en-US" smtClean="0"/>
+              <a:rPr lang="en-US"/>
               <a:t>Click to edit Master text styles</a:t>
             </a:r>
           </a:p>
           <a:p>
             <a:pPr lvl="1"/>
             <a:r>
-              <a:rPr lang="en-US" smtClean="0"/>
+              <a:rPr lang="en-US"/>
               <a:t>Second level</a:t>
             </a:r>
           </a:p>
           <a:p>
             <a:pPr lvl="2"/>
             <a:r>
-              <a:rPr lang="en-US" smtClean="0"/>
+              <a:rPr lang="en-US"/>
               <a:t>Third level</a:t>
             </a:r>
           </a:p>
           <a:p>
             <a:pPr lvl="3"/>
             <a:r>
-              <a:rPr lang="en-US" smtClean="0"/>
+              <a:rPr lang="en-US"/>
               <a:t>Fourth level</a:t>
             </a:r>
           </a:p>
           <a:p>
             <a:pPr lvl="4"/>
             <a:r>
-              <a:rPr lang="en-US" smtClean="0"/>
+              <a:rPr lang="en-US"/>
               <a:t>Fifth level</a:t>
             </a:r>
-            <a:endParaRPr lang="en-US"/>
           </a:p>
         </p:txBody>
       </p:sp>
@@ -1359,7 +1713,7 @@
           <a:p>
             <a:fld id="{5BCAD085-E8A6-8845-BD4E-CB4CCA059FC4}" type="datetimeFigureOut">
               <a:rPr lang="en-US" smtClean="0"/>
-              <a:t>1/27/13</a:t>
+              <a:t>10/22/2025</a:t>
             </a:fld>
             <a:endParaRPr lang="en-US"/>
           </a:p>
@@ -1401,7 +1755,7 @@
           <a:p>
             <a:fld id="{C1FF6DA9-008F-8B48-92A6-B652298478BF}" type="slidenum">
               <a:rPr lang="en-US" smtClean="0"/>
-              <a:t>‹#›</a:t>
+              <a:t>‹Nº›</a:t>
             </a:fld>
             <a:endParaRPr lang="en-US"/>
           </a:p>
@@ -1457,10 +1811,9 @@
           </a:lstStyle>
           <a:p>
             <a:r>
-              <a:rPr lang="en-US" smtClean="0"/>
+              <a:rPr lang="en-US"/>
               <a:t>Click to edit Master title style</a:t>
             </a:r>
-            <a:endParaRPr lang="en-US"/>
           </a:p>
         </p:txBody>
       </p:sp>
@@ -1523,7 +1876,7 @@
           <a:p>
             <a:pPr lvl="0"/>
             <a:r>
-              <a:rPr lang="en-US" smtClean="0"/>
+              <a:rPr lang="en-US"/>
               <a:t>Click to edit Master text styles</a:t>
             </a:r>
           </a:p>
@@ -1579,38 +1932,37 @@
           <a:p>
             <a:pPr lvl="0"/>
             <a:r>
-              <a:rPr lang="en-US" smtClean="0"/>
+              <a:rPr lang="en-US"/>
               <a:t>Click to edit Master text styles</a:t>
             </a:r>
           </a:p>
           <a:p>
             <a:pPr lvl="1"/>
             <a:r>
-              <a:rPr lang="en-US" smtClean="0"/>
+              <a:rPr lang="en-US"/>
               <a:t>Second level</a:t>
             </a:r>
           </a:p>
           <a:p>
             <a:pPr lvl="2"/>
             <a:r>
-              <a:rPr lang="en-US" smtClean="0"/>
+              <a:rPr lang="en-US"/>
               <a:t>Third level</a:t>
             </a:r>
           </a:p>
           <a:p>
             <a:pPr lvl="3"/>
             <a:r>
-              <a:rPr lang="en-US" smtClean="0"/>
+              <a:rPr lang="en-US"/>
               <a:t>Fourth level</a:t>
             </a:r>
           </a:p>
           <a:p>
             <a:pPr lvl="4"/>
             <a:r>
-              <a:rPr lang="en-US" smtClean="0"/>
+              <a:rPr lang="en-US"/>
               <a:t>Fifth level</a:t>
             </a:r>
-            <a:endParaRPr lang="en-US"/>
           </a:p>
         </p:txBody>
       </p:sp>
@@ -1673,7 +2025,7 @@
           <a:p>
             <a:pPr lvl="0"/>
             <a:r>
-              <a:rPr lang="en-US" smtClean="0"/>
+              <a:rPr lang="en-US"/>
               <a:t>Click to edit Master text styles</a:t>
             </a:r>
           </a:p>
@@ -1729,38 +2081,37 @@
           <a:p>
             <a:pPr lvl="0"/>
             <a:r>
-              <a:rPr lang="en-US" smtClean="0"/>
+              <a:rPr lang="en-US"/>
               <a:t>Click to edit Master text styles</a:t>
             </a:r>
           </a:p>
           <a:p>
             <a:pPr lvl="1"/>
             <a:r>
-              <a:rPr lang="en-US" smtClean="0"/>
+              <a:rPr lang="en-US"/>
               <a:t>Second level</a:t>
             </a:r>
           </a:p>
           <a:p>
             <a:pPr lvl="2"/>
             <a:r>
-              <a:rPr lang="en-US" smtClean="0"/>
+              <a:rPr lang="en-US"/>
               <a:t>Third level</a:t>
             </a:r>
           </a:p>
           <a:p>
             <a:pPr lvl="3"/>
             <a:r>
-              <a:rPr lang="en-US" smtClean="0"/>
+              <a:rPr lang="en-US"/>
               <a:t>Fourth level</a:t>
             </a:r>
           </a:p>
           <a:p>
             <a:pPr lvl="4"/>
             <a:r>
-              <a:rPr lang="en-US" smtClean="0"/>
+              <a:rPr lang="en-US"/>
               <a:t>Fifth level</a:t>
             </a:r>
-            <a:endParaRPr lang="en-US"/>
           </a:p>
         </p:txBody>
       </p:sp>
@@ -1781,7 +2132,7 @@
           <a:p>
             <a:fld id="{5BCAD085-E8A6-8845-BD4E-CB4CCA059FC4}" type="datetimeFigureOut">
               <a:rPr lang="en-US" smtClean="0"/>
-              <a:t>1/27/13</a:t>
+              <a:t>10/22/2025</a:t>
             </a:fld>
             <a:endParaRPr lang="en-US"/>
           </a:p>
@@ -1823,7 +2174,7 @@
           <a:p>
             <a:fld id="{C1FF6DA9-008F-8B48-92A6-B652298478BF}" type="slidenum">
               <a:rPr lang="en-US" smtClean="0"/>
-              <a:t>‹#›</a:t>
+              <a:t>‹Nº›</a:t>
             </a:fld>
             <a:endParaRPr lang="en-US"/>
           </a:p>
@@ -1875,10 +2226,9 @@
           <a:lstStyle/>
           <a:p>
             <a:r>
-              <a:rPr lang="en-US" smtClean="0"/>
+              <a:rPr lang="en-US"/>
               <a:t>Click to edit Master title style</a:t>
             </a:r>
-            <a:endParaRPr lang="en-US"/>
           </a:p>
         </p:txBody>
       </p:sp>
@@ -1899,7 +2249,7 @@
           <a:p>
             <a:fld id="{5BCAD085-E8A6-8845-BD4E-CB4CCA059FC4}" type="datetimeFigureOut">
               <a:rPr lang="en-US" smtClean="0"/>
-              <a:t>1/27/13</a:t>
+              <a:t>10/22/2025</a:t>
             </a:fld>
             <a:endParaRPr lang="en-US"/>
           </a:p>
@@ -1941,7 +2291,7 @@
           <a:p>
             <a:fld id="{C1FF6DA9-008F-8B48-92A6-B652298478BF}" type="slidenum">
               <a:rPr lang="en-US" smtClean="0"/>
-              <a:t>‹#›</a:t>
+              <a:t>‹Nº›</a:t>
             </a:fld>
             <a:endParaRPr lang="en-US"/>
           </a:p>
@@ -1994,7 +2344,7 @@
           <a:p>
             <a:fld id="{5BCAD085-E8A6-8845-BD4E-CB4CCA059FC4}" type="datetimeFigureOut">
               <a:rPr lang="en-US" smtClean="0"/>
-              <a:t>1/27/13</a:t>
+              <a:t>10/22/2025</a:t>
             </a:fld>
             <a:endParaRPr lang="en-US"/>
           </a:p>
@@ -2036,7 +2386,7 @@
           <a:p>
             <a:fld id="{C1FF6DA9-008F-8B48-92A6-B652298478BF}" type="slidenum">
               <a:rPr lang="en-US" smtClean="0"/>
-              <a:t>‹#›</a:t>
+              <a:t>‹Nº›</a:t>
             </a:fld>
             <a:endParaRPr lang="en-US"/>
           </a:p>
@@ -2097,10 +2447,9 @@
           </a:lstStyle>
           <a:p>
             <a:r>
-              <a:rPr lang="en-US" smtClean="0"/>
+              <a:rPr lang="en-US"/>
               <a:t>Click to edit Master title style</a:t>
             </a:r>
-            <a:endParaRPr lang="en-US"/>
           </a:p>
         </p:txBody>
       </p:sp>
@@ -2154,38 +2503,37 @@
           <a:p>
             <a:pPr lvl="0"/>
             <a:r>
-              <a:rPr lang="en-US" smtClean="0"/>
+              <a:rPr lang="en-US"/>
               <a:t>Click to edit Master text styles</a:t>
             </a:r>
           </a:p>
           <a:p>
             <a:pPr lvl="1"/>
             <a:r>
-              <a:rPr lang="en-US" smtClean="0"/>
+              <a:rPr lang="en-US"/>
               <a:t>Second level</a:t>
             </a:r>
           </a:p>
           <a:p>
             <a:pPr lvl="2"/>
             <a:r>
-              <a:rPr lang="en-US" smtClean="0"/>
+              <a:rPr lang="en-US"/>
               <a:t>Third level</a:t>
             </a:r>
           </a:p>
           <a:p>
             <a:pPr lvl="3"/>
             <a:r>
-              <a:rPr lang="en-US" smtClean="0"/>
+              <a:rPr lang="en-US"/>
               <a:t>Fourth level</a:t>
             </a:r>
           </a:p>
           <a:p>
             <a:pPr lvl="4"/>
             <a:r>
-              <a:rPr lang="en-US" smtClean="0"/>
+              <a:rPr lang="en-US"/>
               <a:t>Fifth level</a:t>
             </a:r>
-            <a:endParaRPr lang="en-US"/>
           </a:p>
         </p:txBody>
       </p:sp>
@@ -2248,7 +2596,7 @@
           <a:p>
             <a:pPr lvl="0"/>
             <a:r>
-              <a:rPr lang="en-US" smtClean="0"/>
+              <a:rPr lang="en-US"/>
               <a:t>Click to edit Master text styles</a:t>
             </a:r>
           </a:p>
@@ -2271,7 +2619,7 @@
           <a:p>
             <a:fld id="{5BCAD085-E8A6-8845-BD4E-CB4CCA059FC4}" type="datetimeFigureOut">
               <a:rPr lang="en-US" smtClean="0"/>
-              <a:t>1/27/13</a:t>
+              <a:t>10/22/2025</a:t>
             </a:fld>
             <a:endParaRPr lang="en-US"/>
           </a:p>
@@ -2313,7 +2661,7 @@
           <a:p>
             <a:fld id="{C1FF6DA9-008F-8B48-92A6-B652298478BF}" type="slidenum">
               <a:rPr lang="en-US" smtClean="0"/>
-              <a:t>‹#›</a:t>
+              <a:t>‹Nº›</a:t>
             </a:fld>
             <a:endParaRPr lang="en-US"/>
           </a:p>
@@ -2374,10 +2722,9 @@
           </a:lstStyle>
           <a:p>
             <a:r>
-              <a:rPr lang="en-US" smtClean="0"/>
+              <a:rPr lang="en-US"/>
               <a:t>Click to edit Master title style</a:t>
             </a:r>
-            <a:endParaRPr lang="en-US"/>
           </a:p>
         </p:txBody>
       </p:sp>
@@ -2501,7 +2848,7 @@
           <a:p>
             <a:pPr lvl="0"/>
             <a:r>
-              <a:rPr lang="en-US" smtClean="0"/>
+              <a:rPr lang="en-US"/>
               <a:t>Click to edit Master text styles</a:t>
             </a:r>
           </a:p>
@@ -2524,7 +2871,7 @@
           <a:p>
             <a:fld id="{5BCAD085-E8A6-8845-BD4E-CB4CCA059FC4}" type="datetimeFigureOut">
               <a:rPr lang="en-US" smtClean="0"/>
-              <a:t>1/27/13</a:t>
+              <a:t>10/22/2025</a:t>
             </a:fld>
             <a:endParaRPr lang="en-US"/>
           </a:p>
@@ -2566,7 +2913,7 @@
           <a:p>
             <a:fld id="{C1FF6DA9-008F-8B48-92A6-B652298478BF}" type="slidenum">
               <a:rPr lang="en-US" smtClean="0"/>
-              <a:t>‹#›</a:t>
+              <a:t>‹Nº›</a:t>
             </a:fld>
             <a:endParaRPr lang="en-US"/>
           </a:p>
@@ -2633,10 +2980,9 @@
           <a:lstStyle/>
           <a:p>
             <a:r>
-              <a:rPr lang="en-US" smtClean="0"/>
+              <a:rPr lang="en-US"/>
               <a:t>Click to edit Master title style</a:t>
             </a:r>
-            <a:endParaRPr lang="en-US"/>
           </a:p>
         </p:txBody>
       </p:sp>
@@ -2667,38 +3013,37 @@
           <a:p>
             <a:pPr lvl="0"/>
             <a:r>
-              <a:rPr lang="en-US" smtClean="0"/>
+              <a:rPr lang="en-US"/>
               <a:t>Click to edit Master text styles</a:t>
             </a:r>
           </a:p>
           <a:p>
             <a:pPr lvl="1"/>
             <a:r>
-              <a:rPr lang="en-US" smtClean="0"/>
+              <a:rPr lang="en-US"/>
               <a:t>Second level</a:t>
             </a:r>
           </a:p>
           <a:p>
             <a:pPr lvl="2"/>
             <a:r>
-              <a:rPr lang="en-US" smtClean="0"/>
+              <a:rPr lang="en-US"/>
               <a:t>Third level</a:t>
             </a:r>
           </a:p>
           <a:p>
             <a:pPr lvl="3"/>
             <a:r>
-              <a:rPr lang="en-US" smtClean="0"/>
+              <a:rPr lang="en-US"/>
               <a:t>Fourth level</a:t>
             </a:r>
           </a:p>
           <a:p>
             <a:pPr lvl="4"/>
             <a:r>
-              <a:rPr lang="en-US" smtClean="0"/>
+              <a:rPr lang="en-US"/>
               <a:t>Fifth level</a:t>
             </a:r>
-            <a:endParaRPr lang="en-US"/>
           </a:p>
         </p:txBody>
       </p:sp>
@@ -2737,7 +3082,7 @@
           <a:p>
             <a:fld id="{5BCAD085-E8A6-8845-BD4E-CB4CCA059FC4}" type="datetimeFigureOut">
               <a:rPr lang="en-US" smtClean="0"/>
-              <a:t>1/27/13</a:t>
+              <a:t>10/22/2025</a:t>
             </a:fld>
             <a:endParaRPr lang="en-US"/>
           </a:p>
@@ -2815,7 +3160,7 @@
           <a:p>
             <a:fld id="{C1FF6DA9-008F-8B48-92A6-B652298478BF}" type="slidenum">
               <a:rPr lang="en-US" smtClean="0"/>
-              <a:t>‹#›</a:t>
+              <a:t>‹Nº›</a:t>
             </a:fld>
             <a:endParaRPr lang="en-US"/>
           </a:p>
@@ -3096,7 +3441,7 @@
 </file>
 
 <file path=ppt/slides/slide1.xml><?xml version="1.0" encoding="utf-8"?>
-<p:sld xmlns:a="http://schemas.openxmlformats.org/drawingml/2006/main" xmlns:p="http://schemas.openxmlformats.org/presentationml/2006/main" xmlns:r="http://schemas.openxmlformats.org/officeDocument/2006/relationships">
+<p:sld xmlns:a="http://schemas.openxmlformats.org/drawingml/2006/main" xmlns:r="http://schemas.openxmlformats.org/officeDocument/2006/relationships" xmlns:p="http://schemas.openxmlformats.org/presentationml/2006/main">
   <p:cSld>
     <p:spTree>
       <p:nvGrpSpPr>
@@ -3104,7 +3449,14 @@
         <p:cNvGrpSpPr/>
         <p:nvPr/>
       </p:nvGrpSpPr>
-      <p:grpSpPr/>
+      <p:grpSpPr>
+        <a:xfrm>
+          <a:off x="0" y="0"/>
+          <a:ext cx="0" cy="0"/>
+          <a:chOff x="0" y="0"/>
+          <a:chExt cx="0" cy="0"/>
+        </a:xfrm>
+      </p:grpSpPr>
       <p:sp>
         <p:nvSpPr>
           <p:cNvPr id="2" name="Title 1"/>
@@ -3121,7 +3473,7 @@
           <a:lstStyle/>
           <a:p>
             <a:r>
-              <a:t>El Aterrizaje</a:t>
+              <a:t>Propósito</a:t>
             </a:r>
           </a:p>
         </p:txBody>
@@ -3142,13 +3494,12 @@
           <a:lstStyle/>
           <a:p>
             <a:r>
-              <a:t>Una nueva forma de sanar, crecer y transformar vidas</a:t>
-            </a:r>
-          </a:p>
-          <a:p/>
-          <a:p>
-            <a:r>
-              <a:t>Un recurso de Celebremos la Recuperación</a:t>
+              <a:t>Guiar a los adolescentes a una vida más libre y centrada en Dios.</a:t>
+            </a:r>
+          </a:p>
+          <a:p>
+            <a:r>
+              <a:t>Creemos que la verdadera transformación llega cuando te acercas a Jesús.</a:t>
             </a:r>
           </a:p>
         </p:txBody>
@@ -3162,7 +3513,7 @@
 </file>
 
 <file path=ppt/slides/slide10.xml><?xml version="1.0" encoding="utf-8"?>
-<p:sld xmlns:a="http://schemas.openxmlformats.org/drawingml/2006/main" xmlns:p="http://schemas.openxmlformats.org/presentationml/2006/main" xmlns:r="http://schemas.openxmlformats.org/officeDocument/2006/relationships">
+<p:sld xmlns:a="http://schemas.openxmlformats.org/drawingml/2006/main" xmlns:r="http://schemas.openxmlformats.org/officeDocument/2006/relationships" xmlns:p="http://schemas.openxmlformats.org/presentationml/2006/main">
   <p:cSld>
     <p:spTree>
       <p:nvGrpSpPr>
@@ -3170,7 +3521,14 @@
         <p:cNvGrpSpPr/>
         <p:nvPr/>
       </p:nvGrpSpPr>
-      <p:grpSpPr/>
+      <p:grpSpPr>
+        <a:xfrm>
+          <a:off x="0" y="0"/>
+          <a:ext cx="0" cy="0"/>
+          <a:chOff x="0" y="0"/>
+          <a:chExt cx="0" cy="0"/>
+        </a:xfrm>
+      </p:grpSpPr>
       <p:sp>
         <p:nvSpPr>
           <p:cNvPr id="2" name="Title 1"/>
@@ -3187,7 +3545,7 @@
           <a:lstStyle/>
           <a:p>
             <a:r>
-              <a:t>Tiempo de Adoración</a:t>
+              <a:t>Pautas del Grupo</a:t>
             </a:r>
           </a:p>
         </p:txBody>
@@ -3208,12 +3566,27 @@
           <a:lstStyle/>
           <a:p>
             <a:r>
-              <a:t>Cada sesión inicia con adoración.</a:t>
-            </a:r>
-          </a:p>
-          <a:p>
-            <a:r>
-              <a:t>La música conecta el corazón del joven con Dios.</a:t>
+              <a:t>1. Enfócate en tus propios sentimientos</a:t>
+            </a:r>
+          </a:p>
+          <a:p>
+            <a:r>
+              <a:t>2. Evita conversaciones cruzadas</a:t>
+            </a:r>
+          </a:p>
+          <a:p>
+            <a:r>
+              <a:t>3. Apoya sin intentar arreglar</a:t>
+            </a:r>
+          </a:p>
+          <a:p>
+            <a:r>
+              <a:t>4. Confidencialidad total</a:t>
+            </a:r>
+          </a:p>
+          <a:p>
+            <a:r>
+              <a:t>5. Lenguaje edificante</a:t>
             </a:r>
           </a:p>
         </p:txBody>
@@ -3227,7 +3600,7 @@
 </file>
 
 <file path=ppt/slides/slide11.xml><?xml version="1.0" encoding="utf-8"?>
-<p:sld xmlns:a="http://schemas.openxmlformats.org/drawingml/2006/main" xmlns:p="http://schemas.openxmlformats.org/presentationml/2006/main" xmlns:r="http://schemas.openxmlformats.org/officeDocument/2006/relationships">
+<p:sld xmlns:a="http://schemas.openxmlformats.org/drawingml/2006/main" xmlns:r="http://schemas.openxmlformats.org/officeDocument/2006/relationships" xmlns:p="http://schemas.openxmlformats.org/presentationml/2006/main">
   <p:cSld>
     <p:spTree>
       <p:nvGrpSpPr>
@@ -3235,7 +3608,14 @@
         <p:cNvGrpSpPr/>
         <p:nvPr/>
       </p:nvGrpSpPr>
-      <p:grpSpPr/>
+      <p:grpSpPr>
+        <a:xfrm>
+          <a:off x="0" y="0"/>
+          <a:ext cx="0" cy="0"/>
+          <a:chOff x="0" y="0"/>
+          <a:chExt cx="0" cy="0"/>
+        </a:xfrm>
+      </p:grpSpPr>
       <p:sp>
         <p:nvSpPr>
           <p:cNvPr id="2" name="Title 1"/>
@@ -3252,7 +3632,7 @@
           <a:lstStyle/>
           <a:p>
             <a:r>
-              <a:t>Experiencias</a:t>
+              <a:t>Qué Cortar y Qué No</a:t>
             </a:r>
           </a:p>
         </p:txBody>
@@ -3273,12 +3653,12 @@
           <a:lstStyle/>
           <a:p>
             <a:r>
-              <a:t>Las experiencias son el corazón de El Aterrizaje.</a:t>
-            </a:r>
-          </a:p>
-          <a:p>
-            <a:r>
-              <a:t>Actividades vivenciales que enseñan verdades que transforman.</a:t>
+              <a:t>Si hay que reducir tiempo, corta la charla, no la experiencia.</a:t>
+            </a:r>
+          </a:p>
+          <a:p>
+            <a:r>
+              <a:t>El objetivo no es cubrir contenido, sino transformar vidas.</a:t>
             </a:r>
           </a:p>
         </p:txBody>
@@ -3292,7 +3672,7 @@
 </file>
 
 <file path=ppt/slides/slide12.xml><?xml version="1.0" encoding="utf-8"?>
-<p:sld xmlns:a="http://schemas.openxmlformats.org/drawingml/2006/main" xmlns:p="http://schemas.openxmlformats.org/presentationml/2006/main" xmlns:r="http://schemas.openxmlformats.org/officeDocument/2006/relationships">
+<p:sld xmlns:a="http://schemas.openxmlformats.org/drawingml/2006/main" xmlns:r="http://schemas.openxmlformats.org/officeDocument/2006/relationships" xmlns:p="http://schemas.openxmlformats.org/presentationml/2006/main">
   <p:cSld>
     <p:spTree>
       <p:nvGrpSpPr>
@@ -3300,7 +3680,14 @@
         <p:cNvGrpSpPr/>
         <p:nvPr/>
       </p:nvGrpSpPr>
-      <p:grpSpPr/>
+      <p:grpSpPr>
+        <a:xfrm>
+          <a:off x="0" y="0"/>
+          <a:ext cx="0" cy="0"/>
+          <a:chOff x="0" y="0"/>
+          <a:chExt cx="0" cy="0"/>
+        </a:xfrm>
+      </p:grpSpPr>
       <p:sp>
         <p:nvSpPr>
           <p:cNvPr id="2" name="Title 1"/>
@@ -3317,7 +3704,7 @@
           <a:lstStyle/>
           <a:p>
             <a:r>
-              <a:t>Discusión y Grupos Pequeños</a:t>
+              <a:t>Celebración y Avance</a:t>
             </a:r>
           </a:p>
         </p:txBody>
@@ -3338,12 +3725,12 @@
           <a:lstStyle/>
           <a:p>
             <a:r>
-              <a:t>Espacios seguros de confianza y respeto.</a:t>
-            </a:r>
-          </a:p>
-          <a:p>
-            <a:r>
-              <a:t>Se comparten heridas, complejos y hábitos con confidencialidad.</a:t>
+              <a:t>Marcar hitos: Día 1, Semana 2, Mes 1...</a:t>
+            </a:r>
+          </a:p>
+          <a:p>
+            <a:r>
+              <a:t>Celebrar el progreso fortalece la fe y la comunidad.</a:t>
             </a:r>
           </a:p>
         </p:txBody>
@@ -3357,7 +3744,7 @@
 </file>
 
 <file path=ppt/slides/slide13.xml><?xml version="1.0" encoding="utf-8"?>
-<p:sld xmlns:a="http://schemas.openxmlformats.org/drawingml/2006/main" xmlns:p="http://schemas.openxmlformats.org/presentationml/2006/main" xmlns:r="http://schemas.openxmlformats.org/officeDocument/2006/relationships">
+<p:sld xmlns:a="http://schemas.openxmlformats.org/drawingml/2006/main" xmlns:r="http://schemas.openxmlformats.org/officeDocument/2006/relationships" xmlns:p="http://schemas.openxmlformats.org/presentationml/2006/main">
   <p:cSld>
     <p:spTree>
       <p:nvGrpSpPr>
@@ -3365,7 +3752,14 @@
         <p:cNvGrpSpPr/>
         <p:nvPr/>
       </p:nvGrpSpPr>
-      <p:grpSpPr/>
+      <p:grpSpPr>
+        <a:xfrm>
+          <a:off x="0" y="0"/>
+          <a:ext cx="0" cy="0"/>
+          <a:chOff x="0" y="0"/>
+          <a:chExt cx="0" cy="0"/>
+        </a:xfrm>
+      </p:grpSpPr>
       <p:sp>
         <p:nvSpPr>
           <p:cNvPr id="2" name="Title 1"/>
@@ -3382,7 +3776,7 @@
           <a:lstStyle/>
           <a:p>
             <a:r>
-              <a:t>Pautas del Grupo</a:t>
+              <a:t>Cómo Prepararte</a:t>
             </a:r>
           </a:p>
         </p:txBody>
@@ -3403,27 +3797,12 @@
           <a:lstStyle/>
           <a:p>
             <a:r>
-              <a:t>1. Enfócate en tus propios sentimientos</a:t>
-            </a:r>
-          </a:p>
-          <a:p>
-            <a:r>
-              <a:t>2. Evita conversaciones cruzadas</a:t>
-            </a:r>
-          </a:p>
-          <a:p>
-            <a:r>
-              <a:t>3. Apoya sin intentar arreglar</a:t>
-            </a:r>
-          </a:p>
-          <a:p>
-            <a:r>
-              <a:t>4. Confidencialidad total</a:t>
-            </a:r>
-          </a:p>
-          <a:p>
-            <a:r>
-              <a:t>5. Lenguaje edificante</a:t>
+              <a:t>Ora, planifica, revisa materiales, ensaya.</a:t>
+            </a:r>
+          </a:p>
+          <a:p>
+            <a:r>
+              <a:t>Permite que Dios te transforme primero.</a:t>
             </a:r>
           </a:p>
         </p:txBody>
@@ -3437,7 +3816,7 @@
 </file>
 
 <file path=ppt/slides/slide14.xml><?xml version="1.0" encoding="utf-8"?>
-<p:sld xmlns:a="http://schemas.openxmlformats.org/drawingml/2006/main" xmlns:p="http://schemas.openxmlformats.org/presentationml/2006/main" xmlns:r="http://schemas.openxmlformats.org/officeDocument/2006/relationships">
+<p:sld xmlns:a="http://schemas.openxmlformats.org/drawingml/2006/main" xmlns:r="http://schemas.openxmlformats.org/officeDocument/2006/relationships" xmlns:p="http://schemas.openxmlformats.org/presentationml/2006/main">
   <p:cSld>
     <p:spTree>
       <p:nvGrpSpPr>
@@ -3445,7 +3824,14 @@
         <p:cNvGrpSpPr/>
         <p:nvPr/>
       </p:nvGrpSpPr>
-      <p:grpSpPr/>
+      <p:grpSpPr>
+        <a:xfrm>
+          <a:off x="0" y="0"/>
+          <a:ext cx="0" cy="0"/>
+          <a:chOff x="0" y="0"/>
+          <a:chExt cx="0" cy="0"/>
+        </a:xfrm>
+      </p:grpSpPr>
       <p:sp>
         <p:nvSpPr>
           <p:cNvPr id="2" name="Title 1"/>
@@ -3462,7 +3848,7 @@
           <a:lstStyle/>
           <a:p>
             <a:r>
-              <a:t>Qué Cortar y Qué No</a:t>
+              <a:t>Llamado a la Acción</a:t>
             </a:r>
           </a:p>
         </p:txBody>
@@ -3483,12 +3869,12 @@
           <a:lstStyle/>
           <a:p>
             <a:r>
-              <a:t>Si hay que reducir tiempo, corta la charla, no la experiencia.</a:t>
-            </a:r>
-          </a:p>
-          <a:p>
-            <a:r>
-              <a:t>El objetivo no es cubrir contenido, sino transformar vidas.</a:t>
+              <a:t>Sé parte del cambio.</a:t>
+            </a:r>
+          </a:p>
+          <a:p>
+            <a:r>
+              <a:t>Lidera con amor, escucha con empatía, guía con fe.</a:t>
             </a:r>
           </a:p>
         </p:txBody>
@@ -3502,7 +3888,7 @@
 </file>
 
 <file path=ppt/slides/slide15.xml><?xml version="1.0" encoding="utf-8"?>
-<p:sld xmlns:a="http://schemas.openxmlformats.org/drawingml/2006/main" xmlns:p="http://schemas.openxmlformats.org/presentationml/2006/main" xmlns:r="http://schemas.openxmlformats.org/officeDocument/2006/relationships">
+<p:sld xmlns:a="http://schemas.openxmlformats.org/drawingml/2006/main" xmlns:r="http://schemas.openxmlformats.org/officeDocument/2006/relationships" xmlns:p="http://schemas.openxmlformats.org/presentationml/2006/main">
   <p:cSld>
     <p:spTree>
       <p:nvGrpSpPr>
@@ -3510,202 +3896,14 @@
         <p:cNvGrpSpPr/>
         <p:nvPr/>
       </p:nvGrpSpPr>
-      <p:grpSpPr/>
-      <p:sp>
-        <p:nvSpPr>
-          <p:cNvPr id="2" name="Title 1"/>
-          <p:cNvSpPr>
-            <a:spLocks noGrp="1"/>
-          </p:cNvSpPr>
-          <p:nvPr>
-            <p:ph type="title"/>
-          </p:nvPr>
-        </p:nvSpPr>
-        <p:spPr/>
-        <p:txBody>
-          <a:bodyPr/>
-          <a:lstStyle/>
-          <a:p>
-            <a:r>
-              <a:t>Celebración y Avance</a:t>
-            </a:r>
-          </a:p>
-        </p:txBody>
-      </p:sp>
-      <p:sp>
-        <p:nvSpPr>
-          <p:cNvPr id="3" name="Content Placeholder 2"/>
-          <p:cNvSpPr>
-            <a:spLocks noGrp="1"/>
-          </p:cNvSpPr>
-          <p:nvPr>
-            <p:ph idx="1"/>
-          </p:nvPr>
-        </p:nvSpPr>
-        <p:spPr/>
-        <p:txBody>
-          <a:bodyPr/>
-          <a:lstStyle/>
-          <a:p>
-            <a:r>
-              <a:t>Marcar hitos: Día 1, Semana 2, Mes 1...</a:t>
-            </a:r>
-          </a:p>
-          <a:p>
-            <a:r>
-              <a:t>Celebrar el progreso fortalece la fe y la comunidad.</a:t>
-            </a:r>
-          </a:p>
-        </p:txBody>
-      </p:sp>
-    </p:spTree>
-  </p:cSld>
-  <p:clrMapOvr>
-    <a:masterClrMapping/>
-  </p:clrMapOvr>
-</p:sld>
-</file>
-
-<file path=ppt/slides/slide16.xml><?xml version="1.0" encoding="utf-8"?>
-<p:sld xmlns:a="http://schemas.openxmlformats.org/drawingml/2006/main" xmlns:p="http://schemas.openxmlformats.org/presentationml/2006/main" xmlns:r="http://schemas.openxmlformats.org/officeDocument/2006/relationships">
-  <p:cSld>
-    <p:spTree>
-      <p:nvGrpSpPr>
-        <p:cNvPr id="1" name=""/>
-        <p:cNvGrpSpPr/>
-        <p:nvPr/>
-      </p:nvGrpSpPr>
-      <p:grpSpPr/>
-      <p:sp>
-        <p:nvSpPr>
-          <p:cNvPr id="2" name="Title 1"/>
-          <p:cNvSpPr>
-            <a:spLocks noGrp="1"/>
-          </p:cNvSpPr>
-          <p:nvPr>
-            <p:ph type="title"/>
-          </p:nvPr>
-        </p:nvSpPr>
-        <p:spPr/>
-        <p:txBody>
-          <a:bodyPr/>
-          <a:lstStyle/>
-          <a:p>
-            <a:r>
-              <a:t>Cómo Prepararte</a:t>
-            </a:r>
-          </a:p>
-        </p:txBody>
-      </p:sp>
-      <p:sp>
-        <p:nvSpPr>
-          <p:cNvPr id="3" name="Content Placeholder 2"/>
-          <p:cNvSpPr>
-            <a:spLocks noGrp="1"/>
-          </p:cNvSpPr>
-          <p:nvPr>
-            <p:ph idx="1"/>
-          </p:nvPr>
-        </p:nvSpPr>
-        <p:spPr/>
-        <p:txBody>
-          <a:bodyPr/>
-          <a:lstStyle/>
-          <a:p>
-            <a:r>
-              <a:t>Ora, planifica, revisa materiales, ensaya.</a:t>
-            </a:r>
-          </a:p>
-          <a:p>
-            <a:r>
-              <a:t>Permite que Dios te transforme primero.</a:t>
-            </a:r>
-          </a:p>
-        </p:txBody>
-      </p:sp>
-    </p:spTree>
-  </p:cSld>
-  <p:clrMapOvr>
-    <a:masterClrMapping/>
-  </p:clrMapOvr>
-</p:sld>
-</file>
-
-<file path=ppt/slides/slide17.xml><?xml version="1.0" encoding="utf-8"?>
-<p:sld xmlns:a="http://schemas.openxmlformats.org/drawingml/2006/main" xmlns:p="http://schemas.openxmlformats.org/presentationml/2006/main" xmlns:r="http://schemas.openxmlformats.org/officeDocument/2006/relationships">
-  <p:cSld>
-    <p:spTree>
-      <p:nvGrpSpPr>
-        <p:cNvPr id="1" name=""/>
-        <p:cNvGrpSpPr/>
-        <p:nvPr/>
-      </p:nvGrpSpPr>
-      <p:grpSpPr/>
-      <p:sp>
-        <p:nvSpPr>
-          <p:cNvPr id="2" name="Title 1"/>
-          <p:cNvSpPr>
-            <a:spLocks noGrp="1"/>
-          </p:cNvSpPr>
-          <p:nvPr>
-            <p:ph type="title"/>
-          </p:nvPr>
-        </p:nvSpPr>
-        <p:spPr/>
-        <p:txBody>
-          <a:bodyPr/>
-          <a:lstStyle/>
-          <a:p>
-            <a:r>
-              <a:t>Llamado a la Acción</a:t>
-            </a:r>
-          </a:p>
-        </p:txBody>
-      </p:sp>
-      <p:sp>
-        <p:nvSpPr>
-          <p:cNvPr id="3" name="Content Placeholder 2"/>
-          <p:cNvSpPr>
-            <a:spLocks noGrp="1"/>
-          </p:cNvSpPr>
-          <p:nvPr>
-            <p:ph idx="1"/>
-          </p:nvPr>
-        </p:nvSpPr>
-        <p:spPr/>
-        <p:txBody>
-          <a:bodyPr/>
-          <a:lstStyle/>
-          <a:p>
-            <a:r>
-              <a:t>Sé parte del cambio.</a:t>
-            </a:r>
-          </a:p>
-          <a:p>
-            <a:r>
-              <a:t>Lidera con amor, escucha con empatía, guía con fe.</a:t>
-            </a:r>
-          </a:p>
-        </p:txBody>
-      </p:sp>
-    </p:spTree>
-  </p:cSld>
-  <p:clrMapOvr>
-    <a:masterClrMapping/>
-  </p:clrMapOvr>
-</p:sld>
-</file>
-
-<file path=ppt/slides/slide18.xml><?xml version="1.0" encoding="utf-8"?>
-<p:sld xmlns:a="http://schemas.openxmlformats.org/drawingml/2006/main" xmlns:p="http://schemas.openxmlformats.org/presentationml/2006/main" xmlns:r="http://schemas.openxmlformats.org/officeDocument/2006/relationships">
-  <p:cSld>
-    <p:spTree>
-      <p:nvGrpSpPr>
-        <p:cNvPr id="1" name=""/>
-        <p:cNvGrpSpPr/>
-        <p:nvPr/>
-      </p:nvGrpSpPr>
-      <p:grpSpPr/>
+      <p:grpSpPr>
+        <a:xfrm>
+          <a:off x="0" y="0"/>
+          <a:ext cx="0" cy="0"/>
+          <a:chOff x="0" y="0"/>
+          <a:chExt cx="0" cy="0"/>
+        </a:xfrm>
+      </p:grpSpPr>
       <p:sp>
         <p:nvSpPr>
           <p:cNvPr id="2" name="Title 1"/>
@@ -3762,7 +3960,7 @@
 </file>
 
 <file path=ppt/slides/slide2.xml><?xml version="1.0" encoding="utf-8"?>
-<p:sld xmlns:a="http://schemas.openxmlformats.org/drawingml/2006/main" xmlns:p="http://schemas.openxmlformats.org/presentationml/2006/main" xmlns:r="http://schemas.openxmlformats.org/officeDocument/2006/relationships">
+<p:sld xmlns:a="http://schemas.openxmlformats.org/drawingml/2006/main" xmlns:r="http://schemas.openxmlformats.org/officeDocument/2006/relationships" xmlns:p="http://schemas.openxmlformats.org/presentationml/2006/main">
   <p:cSld>
     <p:spTree>
       <p:nvGrpSpPr>
@@ -3770,7 +3968,14 @@
         <p:cNvGrpSpPr/>
         <p:nvPr/>
       </p:nvGrpSpPr>
-      <p:grpSpPr/>
+      <p:grpSpPr>
+        <a:xfrm>
+          <a:off x="0" y="0"/>
+          <a:ext cx="0" cy="0"/>
+          <a:chOff x="0" y="0"/>
+          <a:chExt cx="0" cy="0"/>
+        </a:xfrm>
+      </p:grpSpPr>
       <p:sp>
         <p:nvSpPr>
           <p:cNvPr id="2" name="Title 1"/>
@@ -3787,7 +3992,7 @@
           <a:lstStyle/>
           <a:p>
             <a:r>
-              <a:t>Introducción</a:t>
+              <a:t>Un Programa Vivo</a:t>
             </a:r>
           </a:p>
         </p:txBody>
@@ -3808,12 +4013,12 @@
           <a:lstStyle/>
           <a:p>
             <a:r>
-              <a:t>Bienvenidos a una gran aventura junto a Dios.</a:t>
-            </a:r>
-          </a:p>
-          <a:p>
-            <a:r>
-              <a:t>El Aterrizaje es un viaje transformador de 52 semanas basado en las bienaventuranzas.</a:t>
+              <a:t>El Aterrizaje combina adoración, experiencias, debates y reflexiones.</a:t>
+            </a:r>
+          </a:p>
+          <a:p>
+            <a:r>
+              <a:t>Aprendizaje activo y transformación espiritual.</a:t>
             </a:r>
           </a:p>
         </p:txBody>
@@ -3827,7 +4032,7 @@
 </file>
 
 <file path=ppt/slides/slide3.xml><?xml version="1.0" encoding="utf-8"?>
-<p:sld xmlns:a="http://schemas.openxmlformats.org/drawingml/2006/main" xmlns:p="http://schemas.openxmlformats.org/presentationml/2006/main" xmlns:r="http://schemas.openxmlformats.org/officeDocument/2006/relationships">
+<p:sld xmlns:a="http://schemas.openxmlformats.org/drawingml/2006/main" xmlns:r="http://schemas.openxmlformats.org/officeDocument/2006/relationships" xmlns:p="http://schemas.openxmlformats.org/presentationml/2006/main">
   <p:cSld>
     <p:spTree>
       <p:nvGrpSpPr>
@@ -3835,7 +4040,14 @@
         <p:cNvGrpSpPr/>
         <p:nvPr/>
       </p:nvGrpSpPr>
-      <p:grpSpPr/>
+      <p:grpSpPr>
+        <a:xfrm>
+          <a:off x="0" y="0"/>
+          <a:ext cx="0" cy="0"/>
+          <a:chOff x="0" y="0"/>
+          <a:chExt cx="0" cy="0"/>
+        </a:xfrm>
+      </p:grpSpPr>
       <p:sp>
         <p:nvSpPr>
           <p:cNvPr id="2" name="Title 1"/>
@@ -3852,7 +4064,7 @@
           <a:lstStyle/>
           <a:p>
             <a:r>
-              <a:t>¿Qué es El Aterrizaje?</a:t>
+              <a:t>El Rol del Líder</a:t>
             </a:r>
           </a:p>
         </p:txBody>
@@ -3873,12 +4085,12 @@
           <a:lstStyle/>
           <a:p>
             <a:r>
-              <a:t>Un espacio seguro para adolescentes que buscan sanar, crecer y acercarse a Jesús.</a:t>
-            </a:r>
-          </a:p>
-          <a:p>
-            <a:r>
-              <a:t>No es una clase, es una experiencia.</a:t>
+              <a:t>Más que un maestro: un facilitador, un acompañante, un ejemplo vivo.</a:t>
+            </a:r>
+          </a:p>
+          <a:p>
+            <a:r>
+              <a:t>Dirigir desde la experiencia, no solo desde el conocimiento.</a:t>
             </a:r>
           </a:p>
         </p:txBody>
@@ -3892,7 +4104,7 @@
 </file>
 
 <file path=ppt/slides/slide4.xml><?xml version="1.0" encoding="utf-8"?>
-<p:sld xmlns:a="http://schemas.openxmlformats.org/drawingml/2006/main" xmlns:p="http://schemas.openxmlformats.org/presentationml/2006/main" xmlns:r="http://schemas.openxmlformats.org/officeDocument/2006/relationships">
+<p:sld xmlns:a="http://schemas.openxmlformats.org/drawingml/2006/main" xmlns:r="http://schemas.openxmlformats.org/officeDocument/2006/relationships" xmlns:p="http://schemas.openxmlformats.org/presentationml/2006/main">
   <p:cSld>
     <p:spTree>
       <p:nvGrpSpPr>
@@ -3900,7 +4112,14 @@
         <p:cNvGrpSpPr/>
         <p:nvPr/>
       </p:nvGrpSpPr>
-      <p:grpSpPr/>
+      <p:grpSpPr>
+        <a:xfrm>
+          <a:off x="0" y="0"/>
+          <a:ext cx="0" cy="0"/>
+          <a:chOff x="0" y="0"/>
+          <a:chExt cx="0" cy="0"/>
+        </a:xfrm>
+      </p:grpSpPr>
       <p:sp>
         <p:nvSpPr>
           <p:cNvPr id="2" name="Title 1"/>
@@ -3917,7 +4136,7 @@
           <a:lstStyle/>
           <a:p>
             <a:r>
-              <a:t>Propósito</a:t>
+              <a:t>Campo de Entrenamiento</a:t>
             </a:r>
           </a:p>
         </p:txBody>
@@ -3938,12 +4157,12 @@
           <a:lstStyle/>
           <a:p>
             <a:r>
-              <a:t>Guiar a los adolescentes a una vida más libre y centrada en Dios.</a:t>
-            </a:r>
-          </a:p>
-          <a:p>
-            <a:r>
-              <a:t>Creemos que la verdadera transformación llega cuando te acercas a Jesús.</a:t>
+              <a:t>No es una conferencia, es un proceso de vida.</a:t>
+            </a:r>
+          </a:p>
+          <a:p>
+            <a:r>
+              <a:t>Se utiliza música, videos, dinámicas y oración.</a:t>
             </a:r>
           </a:p>
         </p:txBody>
@@ -3957,7 +4176,7 @@
 </file>
 
 <file path=ppt/slides/slide5.xml><?xml version="1.0" encoding="utf-8"?>
-<p:sld xmlns:a="http://schemas.openxmlformats.org/drawingml/2006/main" xmlns:p="http://schemas.openxmlformats.org/presentationml/2006/main" xmlns:r="http://schemas.openxmlformats.org/officeDocument/2006/relationships">
+<p:sld xmlns:a="http://schemas.openxmlformats.org/drawingml/2006/main" xmlns:r="http://schemas.openxmlformats.org/officeDocument/2006/relationships" xmlns:p="http://schemas.openxmlformats.org/presentationml/2006/main">
   <p:cSld>
     <p:spTree>
       <p:nvGrpSpPr>
@@ -3965,7 +4184,14 @@
         <p:cNvGrpSpPr/>
         <p:nvPr/>
       </p:nvGrpSpPr>
-      <p:grpSpPr/>
+      <p:grpSpPr>
+        <a:xfrm>
+          <a:off x="0" y="0"/>
+          <a:ext cx="0" cy="0"/>
+          <a:chOff x="0" y="0"/>
+          <a:chExt cx="0" cy="0"/>
+        </a:xfrm>
+      </p:grpSpPr>
       <p:sp>
         <p:nvSpPr>
           <p:cNvPr id="2" name="Title 1"/>
@@ -3982,7 +4208,7 @@
           <a:lstStyle/>
           <a:p>
             <a:r>
-              <a:t>Un Programa Vivo</a:t>
+              <a:t>Dinámica de Aprendizaje</a:t>
             </a:r>
           </a:p>
         </p:txBody>
@@ -4003,12 +4229,12 @@
           <a:lstStyle/>
           <a:p>
             <a:r>
-              <a:t>El Aterrizaje combina adoración, experiencias, debates y reflexiones.</a:t>
-            </a:r>
-          </a:p>
-          <a:p>
-            <a:r>
-              <a:t>Aprendizaje activo y transformación espiritual.</a:t>
+              <a:t>Los adolescentes aprenden haciendo.</a:t>
+            </a:r>
+          </a:p>
+          <a:p>
+            <a:r>
+              <a:t>El líder promueve participación, escucha y apertura.</a:t>
             </a:r>
           </a:p>
         </p:txBody>
@@ -4022,7 +4248,7 @@
 </file>
 
 <file path=ppt/slides/slide6.xml><?xml version="1.0" encoding="utf-8"?>
-<p:sld xmlns:a="http://schemas.openxmlformats.org/drawingml/2006/main" xmlns:p="http://schemas.openxmlformats.org/presentationml/2006/main" xmlns:r="http://schemas.openxmlformats.org/officeDocument/2006/relationships">
+<p:sld xmlns:a="http://schemas.openxmlformats.org/drawingml/2006/main" xmlns:r="http://schemas.openxmlformats.org/officeDocument/2006/relationships" xmlns:p="http://schemas.openxmlformats.org/presentationml/2006/main">
   <p:cSld>
     <p:spTree>
       <p:nvGrpSpPr>
@@ -4030,7 +4256,14 @@
         <p:cNvGrpSpPr/>
         <p:nvPr/>
       </p:nvGrpSpPr>
-      <p:grpSpPr/>
+      <p:grpSpPr>
+        <a:xfrm>
+          <a:off x="0" y="0"/>
+          <a:ext cx="0" cy="0"/>
+          <a:chOff x="0" y="0"/>
+          <a:chExt cx="0" cy="0"/>
+        </a:xfrm>
+      </p:grpSpPr>
       <p:sp>
         <p:nvSpPr>
           <p:cNvPr id="2" name="Title 1"/>
@@ -4047,7 +4280,7 @@
           <a:lstStyle/>
           <a:p>
             <a:r>
-              <a:t>El Rol del Líder</a:t>
+              <a:t>El Diario del Estudiante</a:t>
             </a:r>
           </a:p>
         </p:txBody>
@@ -4068,12 +4301,12 @@
           <a:lstStyle/>
           <a:p>
             <a:r>
-              <a:t>Más que un maestro: un facilitador, un acompañante, un ejemplo vivo.</a:t>
-            </a:r>
-          </a:p>
-          <a:p>
-            <a:r>
-              <a:t>Dirigir desde la experiencia, no solo desde el conocimiento.</a:t>
+              <a:t>Una herramienta personal y segura para reflexionar, escribir y crecer.</a:t>
+            </a:r>
+          </a:p>
+          <a:p>
+            <a:r>
+              <a:t>Favorece el proceso de sanidad emocional y espiritual.</a:t>
             </a:r>
           </a:p>
         </p:txBody>
@@ -4087,7 +4320,7 @@
 </file>
 
 <file path=ppt/slides/slide7.xml><?xml version="1.0" encoding="utf-8"?>
-<p:sld xmlns:a="http://schemas.openxmlformats.org/drawingml/2006/main" xmlns:p="http://schemas.openxmlformats.org/presentationml/2006/main" xmlns:r="http://schemas.openxmlformats.org/officeDocument/2006/relationships">
+<p:sld xmlns:a="http://schemas.openxmlformats.org/drawingml/2006/main" xmlns:r="http://schemas.openxmlformats.org/officeDocument/2006/relationships" xmlns:p="http://schemas.openxmlformats.org/presentationml/2006/main">
   <p:cSld>
     <p:spTree>
       <p:nvGrpSpPr>
@@ -4095,7 +4328,14 @@
         <p:cNvGrpSpPr/>
         <p:nvPr/>
       </p:nvGrpSpPr>
-      <p:grpSpPr/>
+      <p:grpSpPr>
+        <a:xfrm>
+          <a:off x="0" y="0"/>
+          <a:ext cx="0" cy="0"/>
+          <a:chOff x="0" y="0"/>
+          <a:chExt cx="0" cy="0"/>
+        </a:xfrm>
+      </p:grpSpPr>
       <p:sp>
         <p:nvSpPr>
           <p:cNvPr id="2" name="Title 1"/>
@@ -4112,7 +4352,7 @@
           <a:lstStyle/>
           <a:p>
             <a:r>
-              <a:t>Campo de Entrenamiento</a:t>
+              <a:t>Tiempo de Adoración</a:t>
             </a:r>
           </a:p>
         </p:txBody>
@@ -4133,12 +4373,12 @@
           <a:lstStyle/>
           <a:p>
             <a:r>
-              <a:t>No es una conferencia, es un proceso de vida.</a:t>
-            </a:r>
-          </a:p>
-          <a:p>
-            <a:r>
-              <a:t>Se utiliza música, videos, dinámicas y oración.</a:t>
+              <a:t>Cada sesión inicia con adoración.</a:t>
+            </a:r>
+          </a:p>
+          <a:p>
+            <a:r>
+              <a:t>La música conecta el corazón del joven con Dios.</a:t>
             </a:r>
           </a:p>
         </p:txBody>
@@ -4152,7 +4392,7 @@
 </file>
 
 <file path=ppt/slides/slide8.xml><?xml version="1.0" encoding="utf-8"?>
-<p:sld xmlns:a="http://schemas.openxmlformats.org/drawingml/2006/main" xmlns:p="http://schemas.openxmlformats.org/presentationml/2006/main" xmlns:r="http://schemas.openxmlformats.org/officeDocument/2006/relationships">
+<p:sld xmlns:a="http://schemas.openxmlformats.org/drawingml/2006/main" xmlns:r="http://schemas.openxmlformats.org/officeDocument/2006/relationships" xmlns:p="http://schemas.openxmlformats.org/presentationml/2006/main">
   <p:cSld>
     <p:spTree>
       <p:nvGrpSpPr>
@@ -4160,7 +4400,14 @@
         <p:cNvGrpSpPr/>
         <p:nvPr/>
       </p:nvGrpSpPr>
-      <p:grpSpPr/>
+      <p:grpSpPr>
+        <a:xfrm>
+          <a:off x="0" y="0"/>
+          <a:ext cx="0" cy="0"/>
+          <a:chOff x="0" y="0"/>
+          <a:chExt cx="0" cy="0"/>
+        </a:xfrm>
+      </p:grpSpPr>
       <p:sp>
         <p:nvSpPr>
           <p:cNvPr id="2" name="Title 1"/>
@@ -4177,7 +4424,7 @@
           <a:lstStyle/>
           <a:p>
             <a:r>
-              <a:t>Dinámica de Aprendizaje</a:t>
+              <a:t>Experiencias</a:t>
             </a:r>
           </a:p>
         </p:txBody>
@@ -4198,12 +4445,12 @@
           <a:lstStyle/>
           <a:p>
             <a:r>
-              <a:t>Los adolescentes aprenden haciendo.</a:t>
-            </a:r>
-          </a:p>
-          <a:p>
-            <a:r>
-              <a:t>El líder promueve participación, escucha y apertura.</a:t>
+              <a:t>Las experiencias son el corazón de El Aterrizaje.</a:t>
+            </a:r>
+          </a:p>
+          <a:p>
+            <a:r>
+              <a:t>Actividades vivenciales que enseñan verdades que transforman.</a:t>
             </a:r>
           </a:p>
         </p:txBody>
@@ -4217,7 +4464,7 @@
 </file>
 
 <file path=ppt/slides/slide9.xml><?xml version="1.0" encoding="utf-8"?>
-<p:sld xmlns:a="http://schemas.openxmlformats.org/drawingml/2006/main" xmlns:p="http://schemas.openxmlformats.org/presentationml/2006/main" xmlns:r="http://schemas.openxmlformats.org/officeDocument/2006/relationships">
+<p:sld xmlns:a="http://schemas.openxmlformats.org/drawingml/2006/main" xmlns:r="http://schemas.openxmlformats.org/officeDocument/2006/relationships" xmlns:p="http://schemas.openxmlformats.org/presentationml/2006/main">
   <p:cSld>
     <p:spTree>
       <p:nvGrpSpPr>
@@ -4225,7 +4472,14 @@
         <p:cNvGrpSpPr/>
         <p:nvPr/>
       </p:nvGrpSpPr>
-      <p:grpSpPr/>
+      <p:grpSpPr>
+        <a:xfrm>
+          <a:off x="0" y="0"/>
+          <a:ext cx="0" cy="0"/>
+          <a:chOff x="0" y="0"/>
+          <a:chExt cx="0" cy="0"/>
+        </a:xfrm>
+      </p:grpSpPr>
       <p:sp>
         <p:nvSpPr>
           <p:cNvPr id="2" name="Title 1"/>
@@ -4242,7 +4496,7 @@
           <a:lstStyle/>
           <a:p>
             <a:r>
-              <a:t>El Diario del Estudiante</a:t>
+              <a:t>Discusión y Grupos Pequeños</a:t>
             </a:r>
           </a:p>
         </p:txBody>
@@ -4263,12 +4517,12 @@
           <a:lstStyle/>
           <a:p>
             <a:r>
-              <a:t>Una herramienta personal y segura para reflexionar, escribir y crecer.</a:t>
-            </a:r>
-          </a:p>
-          <a:p>
-            <a:r>
-              <a:t>Favorece el proceso de sanidad emocional y espiritual.</a:t>
+              <a:t>Espacios seguros de confianza y respeto.</a:t>
+            </a:r>
+          </a:p>
+          <a:p>
+            <a:r>
+              <a:t>Se comparten heridas, complejos y hábitos con confidencialidad.</a:t>
             </a:r>
           </a:p>
         </p:txBody>
@@ -4599,4 +4853,299 @@
   </a:objectDefaults>
   <a:extraClrSchemeLst/>
 </a:theme>
+</file>
+
+<file path=ppt/theme/theme2.xml><?xml version="1.0" encoding="utf-8"?>
+<a:theme xmlns:a="http://schemas.openxmlformats.org/drawingml/2006/main" name="Tema de Office">
+  <a:themeElements>
+    <a:clrScheme name="Office">
+      <a:dk1>
+        <a:sysClr val="windowText" lastClr="000000"/>
+      </a:dk1>
+      <a:lt1>
+        <a:sysClr val="window" lastClr="FFFFFF"/>
+      </a:lt1>
+      <a:dk2>
+        <a:srgbClr val="44546A"/>
+      </a:dk2>
+      <a:lt2>
+        <a:srgbClr val="E7E6E6"/>
+      </a:lt2>
+      <a:accent1>
+        <a:srgbClr val="4472C4"/>
+      </a:accent1>
+      <a:accent2>
+        <a:srgbClr val="ED7D31"/>
+      </a:accent2>
+      <a:accent3>
+        <a:srgbClr val="A5A5A5"/>
+      </a:accent3>
+      <a:accent4>
+        <a:srgbClr val="FFC000"/>
+      </a:accent4>
+      <a:accent5>
+        <a:srgbClr val="5B9BD5"/>
+      </a:accent5>
+      <a:accent6>
+        <a:srgbClr val="70AD47"/>
+      </a:accent6>
+      <a:hlink>
+        <a:srgbClr val="0563C1"/>
+      </a:hlink>
+      <a:folHlink>
+        <a:srgbClr val="954F72"/>
+      </a:folHlink>
+    </a:clrScheme>
+    <a:fontScheme name="Office">
+      <a:majorFont>
+        <a:latin typeface="Calibri Light" panose="020F0302020204030204"/>
+        <a:ea typeface=""/>
+        <a:cs typeface=""/>
+        <a:font script="Jpan" typeface="游ゴシック Light"/>
+        <a:font script="Hang" typeface="맑은 고딕"/>
+        <a:font script="Hans" typeface="等线 Light"/>
+        <a:font script="Hant" typeface="新細明體"/>
+        <a:font script="Arab" typeface="Times New Roman"/>
+        <a:font script="Hebr" typeface="Times New Roman"/>
+        <a:font script="Thai" typeface="Angsana New"/>
+        <a:font script="Ethi" typeface="Nyala"/>
+        <a:font script="Beng" typeface="Vrinda"/>
+        <a:font script="Gujr" typeface="Shruti"/>
+        <a:font script="Khmr" typeface="MoolBoran"/>
+        <a:font script="Knda" typeface="Tunga"/>
+        <a:font script="Guru" typeface="Raavi"/>
+        <a:font script="Cans" typeface="Euphemia"/>
+        <a:font script="Cher" typeface="Plantagenet Cherokee"/>
+        <a:font script="Yiii" typeface="Microsoft Yi Baiti"/>
+        <a:font script="Tibt" typeface="Microsoft Himalaya"/>
+        <a:font script="Thaa" typeface="MV Boli"/>
+        <a:font script="Deva" typeface="Mangal"/>
+        <a:font script="Telu" typeface="Gautami"/>
+        <a:font script="Taml" typeface="Latha"/>
+        <a:font script="Syrc" typeface="Estrangelo Edessa"/>
+        <a:font script="Orya" typeface="Kalinga"/>
+        <a:font script="Mlym" typeface="Kartika"/>
+        <a:font script="Laoo" typeface="DokChampa"/>
+        <a:font script="Sinh" typeface="Iskoola Pota"/>
+        <a:font script="Mong" typeface="Mongolian Baiti"/>
+        <a:font script="Viet" typeface="Times New Roman"/>
+        <a:font script="Uigh" typeface="Microsoft Uighur"/>
+        <a:font script="Geor" typeface="Sylfaen"/>
+        <a:font script="Armn" typeface="Arial"/>
+        <a:font script="Bugi" typeface="Leelawadee UI"/>
+        <a:font script="Bopo" typeface="Microsoft JhengHei"/>
+        <a:font script="Java" typeface="Javanese Text"/>
+        <a:font script="Lisu" typeface="Segoe UI"/>
+        <a:font script="Mymr" typeface="Myanmar Text"/>
+        <a:font script="Nkoo" typeface="Ebrima"/>
+        <a:font script="Olck" typeface="Nirmala UI"/>
+        <a:font script="Osma" typeface="Ebrima"/>
+        <a:font script="Phag" typeface="Phagspa"/>
+        <a:font script="Syrn" typeface="Estrangelo Edessa"/>
+        <a:font script="Syrj" typeface="Estrangelo Edessa"/>
+        <a:font script="Syre" typeface="Estrangelo Edessa"/>
+        <a:font script="Sora" typeface="Nirmala UI"/>
+        <a:font script="Tale" typeface="Microsoft Tai Le"/>
+        <a:font script="Talu" typeface="Microsoft New Tai Lue"/>
+        <a:font script="Tfng" typeface="Ebrima"/>
+      </a:majorFont>
+      <a:minorFont>
+        <a:latin typeface="Calibri" panose="020F0502020204030204"/>
+        <a:ea typeface=""/>
+        <a:cs typeface=""/>
+        <a:font script="Jpan" typeface="游ゴシック"/>
+        <a:font script="Hang" typeface="맑은 고딕"/>
+        <a:font script="Hans" typeface="等线"/>
+        <a:font script="Hant" typeface="新細明體"/>
+        <a:font script="Arab" typeface="Arial"/>
+        <a:font script="Hebr" typeface="Arial"/>
+        <a:font script="Thai" typeface="Cordia New"/>
+        <a:font script="Ethi" typeface="Nyala"/>
+        <a:font script="Beng" typeface="Vrinda"/>
+        <a:font script="Gujr" typeface="Shruti"/>
+        <a:font script="Khmr" typeface="DaunPenh"/>
+        <a:font script="Knda" typeface="Tunga"/>
+        <a:font script="Guru" typeface="Raavi"/>
+        <a:font script="Cans" typeface="Euphemia"/>
+        <a:font script="Cher" typeface="Plantagenet Cherokee"/>
+        <a:font script="Yiii" typeface="Microsoft Yi Baiti"/>
+        <a:font script="Tibt" typeface="Microsoft Himalaya"/>
+        <a:font script="Thaa" typeface="MV Boli"/>
+        <a:font script="Deva" typeface="Mangal"/>
+        <a:font script="Telu" typeface="Gautami"/>
+        <a:font script="Taml" typeface="Latha"/>
+        <a:font script="Syrc" typeface="Estrangelo Edessa"/>
+        <a:font script="Orya" typeface="Kalinga"/>
+        <a:font script="Mlym" typeface="Kartika"/>
+        <a:font script="Laoo" typeface="DokChampa"/>
+        <a:font script="Sinh" typeface="Iskoola Pota"/>
+        <a:font script="Mong" typeface="Mongolian Baiti"/>
+        <a:font script="Viet" typeface="Arial"/>
+        <a:font script="Uigh" typeface="Microsoft Uighur"/>
+        <a:font script="Geor" typeface="Sylfaen"/>
+        <a:font script="Armn" typeface="Arial"/>
+        <a:font script="Bugi" typeface="Leelawadee UI"/>
+        <a:font script="Bopo" typeface="Microsoft JhengHei"/>
+        <a:font script="Java" typeface="Javanese Text"/>
+        <a:font script="Lisu" typeface="Segoe UI"/>
+        <a:font script="Mymr" typeface="Myanmar Text"/>
+        <a:font script="Nkoo" typeface="Ebrima"/>
+        <a:font script="Olck" typeface="Nirmala UI"/>
+        <a:font script="Osma" typeface="Ebrima"/>
+        <a:font script="Phag" typeface="Phagspa"/>
+        <a:font script="Syrn" typeface="Estrangelo Edessa"/>
+        <a:font script="Syrj" typeface="Estrangelo Edessa"/>
+        <a:font script="Syre" typeface="Estrangelo Edessa"/>
+        <a:font script="Sora" typeface="Nirmala UI"/>
+        <a:font script="Tale" typeface="Microsoft Tai Le"/>
+        <a:font script="Talu" typeface="Microsoft New Tai Lue"/>
+        <a:font script="Tfng" typeface="Ebrima"/>
+      </a:minorFont>
+    </a:fontScheme>
+    <a:fmtScheme name="Office">
+      <a:fillStyleLst>
+        <a:solidFill>
+          <a:schemeClr val="phClr"/>
+        </a:solidFill>
+        <a:gradFill rotWithShape="1">
+          <a:gsLst>
+            <a:gs pos="0">
+              <a:schemeClr val="phClr">
+                <a:lumMod val="110000"/>
+                <a:satMod val="105000"/>
+                <a:tint val="67000"/>
+              </a:schemeClr>
+            </a:gs>
+            <a:gs pos="50000">
+              <a:schemeClr val="phClr">
+                <a:lumMod val="105000"/>
+                <a:satMod val="103000"/>
+                <a:tint val="73000"/>
+              </a:schemeClr>
+            </a:gs>
+            <a:gs pos="100000">
+              <a:schemeClr val="phClr">
+                <a:lumMod val="105000"/>
+                <a:satMod val="109000"/>
+                <a:tint val="81000"/>
+              </a:schemeClr>
+            </a:gs>
+          </a:gsLst>
+          <a:lin ang="5400000" scaled="0"/>
+        </a:gradFill>
+        <a:gradFill rotWithShape="1">
+          <a:gsLst>
+            <a:gs pos="0">
+              <a:schemeClr val="phClr">
+                <a:satMod val="103000"/>
+                <a:lumMod val="102000"/>
+                <a:tint val="94000"/>
+              </a:schemeClr>
+            </a:gs>
+            <a:gs pos="50000">
+              <a:schemeClr val="phClr">
+                <a:satMod val="110000"/>
+                <a:lumMod val="100000"/>
+                <a:shade val="100000"/>
+              </a:schemeClr>
+            </a:gs>
+            <a:gs pos="100000">
+              <a:schemeClr val="phClr">
+                <a:lumMod val="99000"/>
+                <a:satMod val="120000"/>
+                <a:shade val="78000"/>
+              </a:schemeClr>
+            </a:gs>
+          </a:gsLst>
+          <a:lin ang="5400000" scaled="0"/>
+        </a:gradFill>
+      </a:fillStyleLst>
+      <a:lnStyleLst>
+        <a:ln w="6350" cap="flat" cmpd="sng" algn="ctr">
+          <a:solidFill>
+            <a:schemeClr val="phClr"/>
+          </a:solidFill>
+          <a:prstDash val="solid"/>
+          <a:miter lim="800000"/>
+        </a:ln>
+        <a:ln w="12700" cap="flat" cmpd="sng" algn="ctr">
+          <a:solidFill>
+            <a:schemeClr val="phClr"/>
+          </a:solidFill>
+          <a:prstDash val="solid"/>
+          <a:miter lim="800000"/>
+        </a:ln>
+        <a:ln w="19050" cap="flat" cmpd="sng" algn="ctr">
+          <a:solidFill>
+            <a:schemeClr val="phClr"/>
+          </a:solidFill>
+          <a:prstDash val="solid"/>
+          <a:miter lim="800000"/>
+        </a:ln>
+      </a:lnStyleLst>
+      <a:effectStyleLst>
+        <a:effectStyle>
+          <a:effectLst/>
+        </a:effectStyle>
+        <a:effectStyle>
+          <a:effectLst/>
+        </a:effectStyle>
+        <a:effectStyle>
+          <a:effectLst>
+            <a:outerShdw blurRad="57150" dist="19050" dir="5400000" algn="ctr" rotWithShape="0">
+              <a:srgbClr val="000000">
+                <a:alpha val="63000"/>
+              </a:srgbClr>
+            </a:outerShdw>
+          </a:effectLst>
+        </a:effectStyle>
+      </a:effectStyleLst>
+      <a:bgFillStyleLst>
+        <a:solidFill>
+          <a:schemeClr val="phClr"/>
+        </a:solidFill>
+        <a:solidFill>
+          <a:schemeClr val="phClr">
+            <a:tint val="95000"/>
+            <a:satMod val="170000"/>
+          </a:schemeClr>
+        </a:solidFill>
+        <a:gradFill rotWithShape="1">
+          <a:gsLst>
+            <a:gs pos="0">
+              <a:schemeClr val="phClr">
+                <a:tint val="93000"/>
+                <a:satMod val="150000"/>
+                <a:shade val="98000"/>
+                <a:lumMod val="102000"/>
+              </a:schemeClr>
+            </a:gs>
+            <a:gs pos="50000">
+              <a:schemeClr val="phClr">
+                <a:tint val="98000"/>
+                <a:satMod val="130000"/>
+                <a:shade val="90000"/>
+                <a:lumMod val="103000"/>
+              </a:schemeClr>
+            </a:gs>
+            <a:gs pos="100000">
+              <a:schemeClr val="phClr">
+                <a:shade val="63000"/>
+                <a:satMod val="120000"/>
+              </a:schemeClr>
+            </a:gs>
+          </a:gsLst>
+          <a:lin ang="5400000" scaled="0"/>
+        </a:gradFill>
+      </a:bgFillStyleLst>
+    </a:fmtScheme>
+  </a:themeElements>
+  <a:objectDefaults/>
+  <a:extraClrSchemeLst/>
+  <a:extLst>
+    <a:ext uri="{05A4C25C-085E-4340-85A3-A5531E510DB2}">
+      <thm15:themeFamily xmlns:thm15="http://schemas.microsoft.com/office/thememl/2012/main" name="Office Theme" id="{62F939B6-93AF-4DB8-9C6B-D6C7DFDC589F}" vid="{4A3C46E8-61CC-4603-A589-7422A47A8E4A}"/>
+    </a:ext>
+  </a:extLst>
+</a:theme>
 </file>
</xml_diff>